<commit_message>
Docs: Final visual edits and graphic integration completed for presentation deck
</commit_message>
<xml_diff>
--- a/Presentation/HR Presentation.pptx
+++ b/Presentation/HR Presentation.pptx
@@ -14,8 +14,6 @@
     <p:sldId id="280" r:id="rId8"/>
     <p:sldId id="281" r:id="rId9"/>
     <p:sldId id="282" r:id="rId10"/>
-    <p:sldId id="276" r:id="rId11"/>
-    <p:sldId id="277" r:id="rId12"/>
   </p:sldIdLst>
   <p:sldSz cx="12192000" cy="6858000"/>
   <p:notesSz cx="6858000" cy="9144000"/>
@@ -114,6 +112,11 @@
       </a:defRPr>
     </a:lvl9pPr>
   </p:defaultTextStyle>
+  <p:extLst>
+    <p:ext uri="{EFAFB233-063F-42B5-8137-9DF3F51BA10A}">
+      <p15:sldGuideLst xmlns:p15="http://schemas.microsoft.com/office/powerpoint/2012/main"/>
+    </p:ext>
+  </p:extLst>
 </p:presentation>
 </file>
 
@@ -3462,8 +3465,8 @@
         </p:nvSpPr>
         <p:spPr>
           <a:xfrm>
-            <a:off x="7086601" y="3639630"/>
-            <a:ext cx="6100010" cy="2554545"/>
+            <a:off x="7167561" y="3811012"/>
+            <a:ext cx="6100010" cy="3046988"/>
           </a:xfrm>
           <a:prstGeom prst="rect">
             <a:avLst/>
@@ -3540,6 +3543,36 @@
               </a:rPr>
               <a:t>Hamdeen</a:t>
             </a:r>
+            <a:endParaRPr lang="en-US" sz="3200" b="1" i="0" dirty="0">
+              <a:solidFill>
+                <a:schemeClr val="bg1"/>
+              </a:solidFill>
+              <a:effectLst/>
+              <a:latin typeface="Arial" panose="020B0604020202020204" pitchFamily="34" charset="0"/>
+              <a:cs typeface="Arial" panose="020B0604020202020204" pitchFamily="34" charset="0"/>
+            </a:endParaRPr>
+          </a:p>
+          <a:p>
+            <a:r>
+              <a:rPr lang="en-US" sz="3200" b="1" dirty="0">
+                <a:solidFill>
+                  <a:schemeClr val="bg1"/>
+                </a:solidFill>
+                <a:latin typeface="Arial" panose="020B0604020202020204" pitchFamily="34" charset="0"/>
+                <a:cs typeface="Arial" panose="020B0604020202020204" pitchFamily="34" charset="0"/>
+              </a:rPr>
+              <a:t>Aya </a:t>
+            </a:r>
+            <a:r>
+              <a:rPr lang="en-US" sz="3200" b="1" dirty="0" err="1">
+                <a:solidFill>
+                  <a:schemeClr val="bg1"/>
+                </a:solidFill>
+                <a:latin typeface="Arial" panose="020B0604020202020204" pitchFamily="34" charset="0"/>
+                <a:cs typeface="Arial" panose="020B0604020202020204" pitchFamily="34" charset="0"/>
+              </a:rPr>
+              <a:t>Moustafa</a:t>
+            </a:r>
             <a:endParaRPr lang="en-US" sz="3200" b="1" dirty="0">
               <a:solidFill>
                 <a:schemeClr val="bg1"/>
@@ -3562,37 +3595,17 @@
               <a:t>Nada </a:t>
             </a:r>
             <a:r>
-              <a:rPr lang="en-US" sz="3200" b="1" i="0" dirty="0" err="1">
-                <a:solidFill>
-                  <a:schemeClr val="bg1"/>
-                </a:solidFill>
-                <a:effectLst/>
-                <a:latin typeface="Arial" panose="020B0604020202020204" pitchFamily="34" charset="0"/>
-                <a:cs typeface="Arial" panose="020B0604020202020204" pitchFamily="34" charset="0"/>
-              </a:rPr>
-              <a:t>Gaballah</a:t>
-            </a:r>
-            <a:endParaRPr lang="en-US" sz="3200" b="1" dirty="0">
-              <a:solidFill>
-                <a:schemeClr val="bg1"/>
-              </a:solidFill>
-              <a:effectLst/>
-              <a:latin typeface="Arial" panose="020B0604020202020204" pitchFamily="34" charset="0"/>
-              <a:cs typeface="Arial" panose="020B0604020202020204" pitchFamily="34" charset="0"/>
-            </a:endParaRPr>
-          </a:p>
-          <a:p>
-            <a:r>
-              <a:rPr lang="en-US" sz="3200" b="1" i="0" dirty="0">
-                <a:solidFill>
-                  <a:schemeClr val="bg1"/>
-                </a:solidFill>
-                <a:effectLst/>
-                <a:latin typeface="Arial" panose="020B0604020202020204" pitchFamily="34" charset="0"/>
-                <a:cs typeface="Arial" panose="020B0604020202020204" pitchFamily="34" charset="0"/>
-              </a:rPr>
-              <a:t>Aya Mohamed</a:t>
-            </a:r>
+              <a:rPr lang="en-US" sz="3200" b="1" dirty="0">
+                <a:solidFill>
+                  <a:schemeClr val="bg1"/>
+                </a:solidFill>
+                <a:latin typeface="Arial" panose="020B0604020202020204" pitchFamily="34" charset="0"/>
+                <a:cs typeface="Arial" panose="020B0604020202020204" pitchFamily="34" charset="0"/>
+              </a:rPr>
+              <a:t>Mahmoud</a:t>
+            </a:r>
+          </a:p>
+          <a:p>
             <a:endParaRPr lang="en-US" sz="3200" b="1" dirty="0">
               <a:solidFill>
                 <a:schemeClr val="bg1"/>
@@ -3640,6 +3653,48 @@
           </a:prstGeom>
         </p:spPr>
       </p:pic>
+      <p:sp>
+        <p:nvSpPr>
+          <p:cNvPr id="6" name="TextBox 5">
+            <a:extLst>
+              <a:ext uri="{FF2B5EF4-FFF2-40B4-BE49-F238E27FC236}">
+                <a16:creationId xmlns:a16="http://schemas.microsoft.com/office/drawing/2014/main" id="{955D9FEB-6CD8-4591-AB0B-144233B0C22F}"/>
+              </a:ext>
+            </a:extLst>
+          </p:cNvPr>
+          <p:cNvSpPr txBox="1"/>
+          <p:nvPr/>
+        </p:nvSpPr>
+        <p:spPr>
+          <a:xfrm>
+            <a:off x="1020277" y="6101843"/>
+            <a:ext cx="4305702" cy="584775"/>
+          </a:xfrm>
+          <a:prstGeom prst="rect">
+            <a:avLst/>
+          </a:prstGeom>
+          <a:noFill/>
+        </p:spPr>
+        <p:txBody>
+          <a:bodyPr wrap="square">
+            <a:spAutoFit/>
+          </a:bodyPr>
+          <a:lstStyle/>
+          <a:p>
+            <a:r>
+              <a:rPr lang="en-US" sz="3200" b="1" dirty="0">
+                <a:solidFill>
+                  <a:schemeClr val="bg1"/>
+                </a:solidFill>
+                <a:effectLst/>
+                <a:latin typeface="Arial" panose="020B0604020202020204" pitchFamily="34" charset="0"/>
+                <a:cs typeface="Arial" panose="020B0604020202020204" pitchFamily="34" charset="0"/>
+              </a:rPr>
+              <a:t>NHA-ALX3-DAT1-G3</a:t>
+            </a:r>
+          </a:p>
+        </p:txBody>
+      </p:sp>
     </p:spTree>
     <p:extLst>
       <p:ext uri="{BB962C8B-B14F-4D97-AF65-F5344CB8AC3E}">
@@ -3650,372 +3705,18 @@
   <p:clrMapOvr>
     <a:masterClrMapping/>
   </p:clrMapOvr>
-</p:sld>
-</file>
-
-<file path=ppt/slides/slide10.xml><?xml version="1.0" encoding="utf-8"?>
-<p:sld xmlns:a="http://schemas.openxmlformats.org/drawingml/2006/main" xmlns:r="http://schemas.openxmlformats.org/officeDocument/2006/relationships" xmlns:p="http://schemas.openxmlformats.org/presentationml/2006/main">
-  <p:cSld>
-    <p:spTree>
-      <p:nvGrpSpPr>
-        <p:cNvPr id="1" name=""/>
-        <p:cNvGrpSpPr/>
-        <p:nvPr/>
-      </p:nvGrpSpPr>
-      <p:grpSpPr>
-        <a:xfrm>
-          <a:off x="0" y="0"/>
-          <a:ext cx="0" cy="0"/>
-          <a:chOff x="0" y="0"/>
-          <a:chExt cx="0" cy="0"/>
-        </a:xfrm>
-      </p:grpSpPr>
-      <p:sp>
-        <p:nvSpPr>
-          <p:cNvPr id="8" name="Title 7">
-            <a:extLst>
-              <a:ext uri="{FF2B5EF4-FFF2-40B4-BE49-F238E27FC236}">
-                <a16:creationId xmlns:a16="http://schemas.microsoft.com/office/drawing/2014/main" id="{658724C2-AA3C-463E-BA7F-66917BC7A333}"/>
-              </a:ext>
-            </a:extLst>
-          </p:cNvPr>
-          <p:cNvSpPr>
-            <a:spLocks noGrp="1"/>
-          </p:cNvSpPr>
-          <p:nvPr>
-            <p:ph type="title"/>
-          </p:nvPr>
-        </p:nvSpPr>
-        <p:spPr>
-          <a:xfrm>
-            <a:off x="224589" y="365125"/>
-            <a:ext cx="11710737" cy="1325563"/>
-          </a:xfrm>
-        </p:spPr>
-        <p:txBody>
-          <a:bodyPr/>
-          <a:lstStyle/>
-          <a:p>
-            <a:r>
-              <a:rPr lang="en-US" b="1" dirty="0">
-                <a:solidFill>
-                  <a:schemeClr val="bg1"/>
-                </a:solidFill>
-                <a:latin typeface="Arial" panose="020B0604020202020204" pitchFamily="34" charset="0"/>
-                <a:cs typeface="Arial" panose="020B0604020202020204" pitchFamily="34" charset="0"/>
-              </a:rPr>
-              <a:t>Executive Summary (The "Bottom Line")</a:t>
-            </a:r>
-          </a:p>
-        </p:txBody>
-      </p:sp>
-      <p:sp>
-        <p:nvSpPr>
-          <p:cNvPr id="9" name="Content Placeholder 8">
-            <a:extLst>
-              <a:ext uri="{FF2B5EF4-FFF2-40B4-BE49-F238E27FC236}">
-                <a16:creationId xmlns:a16="http://schemas.microsoft.com/office/drawing/2014/main" id="{58DE8E8D-A5A9-46A2-AD26-B6EE25640764}"/>
-              </a:ext>
-            </a:extLst>
-          </p:cNvPr>
-          <p:cNvSpPr>
-            <a:spLocks noGrp="1"/>
-          </p:cNvSpPr>
-          <p:nvPr>
-            <p:ph sz="half" idx="1"/>
-          </p:nvPr>
-        </p:nvSpPr>
-        <p:spPr>
-          <a:xfrm>
-            <a:off x="224589" y="1825625"/>
-            <a:ext cx="5795211" cy="4667250"/>
-          </a:xfrm>
-        </p:spPr>
-        <p:txBody>
-          <a:bodyPr>
-            <a:normAutofit/>
-          </a:bodyPr>
-          <a:lstStyle/>
-          <a:p>
-            <a:endParaRPr lang="en-US" sz="2400" dirty="0">
-              <a:solidFill>
-                <a:schemeClr val="bg1"/>
-              </a:solidFill>
-              <a:latin typeface="Arial" panose="020B0604020202020204" pitchFamily="34" charset="0"/>
-              <a:ea typeface="+mj-ea"/>
-              <a:cs typeface="Arial" panose="020B0604020202020204" pitchFamily="34" charset="0"/>
-            </a:endParaRPr>
-          </a:p>
-        </p:txBody>
-      </p:sp>
-      <p:sp>
-        <p:nvSpPr>
-          <p:cNvPr id="10" name="Content Placeholder 9">
-            <a:extLst>
-              <a:ext uri="{FF2B5EF4-FFF2-40B4-BE49-F238E27FC236}">
-                <a16:creationId xmlns:a16="http://schemas.microsoft.com/office/drawing/2014/main" id="{C2C8480B-C250-44C5-862E-759728BB8DE4}"/>
-              </a:ext>
-            </a:extLst>
-          </p:cNvPr>
-          <p:cNvSpPr>
-            <a:spLocks noGrp="1"/>
-          </p:cNvSpPr>
-          <p:nvPr>
-            <p:ph sz="half" idx="2"/>
-          </p:nvPr>
-        </p:nvSpPr>
-        <p:spPr>
-          <a:xfrm>
-            <a:off x="6172200" y="1825625"/>
-            <a:ext cx="5763126" cy="4667250"/>
-          </a:xfrm>
-        </p:spPr>
-        <p:txBody>
-          <a:bodyPr>
-            <a:normAutofit/>
-          </a:bodyPr>
-          <a:lstStyle/>
-          <a:p>
-            <a:endParaRPr lang="en-US" sz="2400" dirty="0">
-              <a:solidFill>
-                <a:schemeClr val="bg1"/>
-              </a:solidFill>
-              <a:latin typeface="Arial" panose="020B0604020202020204" pitchFamily="34" charset="0"/>
-              <a:ea typeface="+mj-ea"/>
-              <a:cs typeface="Arial" panose="020B0604020202020204" pitchFamily="34" charset="0"/>
-            </a:endParaRPr>
-          </a:p>
-        </p:txBody>
-      </p:sp>
-      <p:pic>
-        <p:nvPicPr>
-          <p:cNvPr id="5" name="Picture 4">
-            <a:extLst>
-              <a:ext uri="{FF2B5EF4-FFF2-40B4-BE49-F238E27FC236}">
-                <a16:creationId xmlns:a16="http://schemas.microsoft.com/office/drawing/2014/main" id="{8425D705-E99B-4E0F-AF12-D0737A2EAB5C}"/>
-              </a:ext>
-            </a:extLst>
-          </p:cNvPr>
-          <p:cNvPicPr>
-            <a:picLocks noChangeAspect="1"/>
-          </p:cNvPicPr>
-          <p:nvPr/>
-        </p:nvPicPr>
-        <p:blipFill>
-          <a:blip r:embed="rId2">
-            <a:extLst>
-              <a:ext uri="{28A0092B-C50C-407E-A947-70E740481C1C}">
-                <a14:useLocalDpi xmlns:a14="http://schemas.microsoft.com/office/drawing/2010/main" val="0"/>
-              </a:ext>
-            </a:extLst>
-          </a:blip>
-          <a:stretch>
-            <a:fillRect/>
-          </a:stretch>
-        </p:blipFill>
-        <p:spPr>
-          <a:xfrm>
-            <a:off x="10985405" y="-352510"/>
-            <a:ext cx="1206595" cy="1206595"/>
-          </a:xfrm>
-          <a:prstGeom prst="rect">
-            <a:avLst/>
-          </a:prstGeom>
-        </p:spPr>
-      </p:pic>
-    </p:spTree>
-    <p:extLst>
-      <p:ext uri="{BB962C8B-B14F-4D97-AF65-F5344CB8AC3E}">
-        <p14:creationId xmlns:p14="http://schemas.microsoft.com/office/powerpoint/2010/main" val="3474409400"/>
-      </p:ext>
-    </p:extLst>
-  </p:cSld>
-  <p:clrMapOvr>
-    <a:masterClrMapping/>
-  </p:clrMapOvr>
-</p:sld>
-</file>
-
-<file path=ppt/slides/slide11.xml><?xml version="1.0" encoding="utf-8"?>
-<p:sld xmlns:a="http://schemas.openxmlformats.org/drawingml/2006/main" xmlns:r="http://schemas.openxmlformats.org/officeDocument/2006/relationships" xmlns:p="http://schemas.openxmlformats.org/presentationml/2006/main">
-  <p:cSld>
-    <p:spTree>
-      <p:nvGrpSpPr>
-        <p:cNvPr id="1" name=""/>
-        <p:cNvGrpSpPr/>
-        <p:nvPr/>
-      </p:nvGrpSpPr>
-      <p:grpSpPr>
-        <a:xfrm>
-          <a:off x="0" y="0"/>
-          <a:ext cx="0" cy="0"/>
-          <a:chOff x="0" y="0"/>
-          <a:chExt cx="0" cy="0"/>
-        </a:xfrm>
-      </p:grpSpPr>
-      <p:sp>
-        <p:nvSpPr>
-          <p:cNvPr id="8" name="Title 7">
-            <a:extLst>
-              <a:ext uri="{FF2B5EF4-FFF2-40B4-BE49-F238E27FC236}">
-                <a16:creationId xmlns:a16="http://schemas.microsoft.com/office/drawing/2014/main" id="{658724C2-AA3C-463E-BA7F-66917BC7A333}"/>
-              </a:ext>
-            </a:extLst>
-          </p:cNvPr>
-          <p:cNvSpPr>
-            <a:spLocks noGrp="1"/>
-          </p:cNvSpPr>
-          <p:nvPr>
-            <p:ph type="title"/>
-          </p:nvPr>
-        </p:nvSpPr>
-        <p:spPr>
-          <a:xfrm>
-            <a:off x="224589" y="365125"/>
-            <a:ext cx="11710737" cy="1325563"/>
-          </a:xfrm>
-        </p:spPr>
-        <p:txBody>
-          <a:bodyPr/>
-          <a:lstStyle/>
-          <a:p>
-            <a:r>
-              <a:rPr lang="en-US" b="1" dirty="0">
-                <a:solidFill>
-                  <a:schemeClr val="bg1"/>
-                </a:solidFill>
-                <a:latin typeface="Arial" panose="020B0604020202020204" pitchFamily="34" charset="0"/>
-                <a:cs typeface="Arial" panose="020B0604020202020204" pitchFamily="34" charset="0"/>
-              </a:rPr>
-              <a:t>Executive Summary (The "Bottom Line")</a:t>
-            </a:r>
-          </a:p>
-        </p:txBody>
-      </p:sp>
-      <p:sp>
-        <p:nvSpPr>
-          <p:cNvPr id="9" name="Content Placeholder 8">
-            <a:extLst>
-              <a:ext uri="{FF2B5EF4-FFF2-40B4-BE49-F238E27FC236}">
-                <a16:creationId xmlns:a16="http://schemas.microsoft.com/office/drawing/2014/main" id="{58DE8E8D-A5A9-46A2-AD26-B6EE25640764}"/>
-              </a:ext>
-            </a:extLst>
-          </p:cNvPr>
-          <p:cNvSpPr>
-            <a:spLocks noGrp="1"/>
-          </p:cNvSpPr>
-          <p:nvPr>
-            <p:ph sz="half" idx="1"/>
-          </p:nvPr>
-        </p:nvSpPr>
-        <p:spPr>
-          <a:xfrm>
-            <a:off x="224589" y="1825625"/>
-            <a:ext cx="5795211" cy="4667250"/>
-          </a:xfrm>
-        </p:spPr>
-        <p:txBody>
-          <a:bodyPr>
-            <a:normAutofit/>
-          </a:bodyPr>
-          <a:lstStyle/>
-          <a:p>
-            <a:endParaRPr lang="en-US" sz="2400" dirty="0">
-              <a:solidFill>
-                <a:schemeClr val="bg1"/>
-              </a:solidFill>
-              <a:latin typeface="Arial" panose="020B0604020202020204" pitchFamily="34" charset="0"/>
-              <a:ea typeface="+mj-ea"/>
-              <a:cs typeface="Arial" panose="020B0604020202020204" pitchFamily="34" charset="0"/>
-            </a:endParaRPr>
-          </a:p>
-        </p:txBody>
-      </p:sp>
-      <p:sp>
-        <p:nvSpPr>
-          <p:cNvPr id="10" name="Content Placeholder 9">
-            <a:extLst>
-              <a:ext uri="{FF2B5EF4-FFF2-40B4-BE49-F238E27FC236}">
-                <a16:creationId xmlns:a16="http://schemas.microsoft.com/office/drawing/2014/main" id="{C2C8480B-C250-44C5-862E-759728BB8DE4}"/>
-              </a:ext>
-            </a:extLst>
-          </p:cNvPr>
-          <p:cNvSpPr>
-            <a:spLocks noGrp="1"/>
-          </p:cNvSpPr>
-          <p:nvPr>
-            <p:ph sz="half" idx="2"/>
-          </p:nvPr>
-        </p:nvSpPr>
-        <p:spPr>
-          <a:xfrm>
-            <a:off x="6172200" y="1825625"/>
-            <a:ext cx="5763126" cy="4667250"/>
-          </a:xfrm>
-        </p:spPr>
-        <p:txBody>
-          <a:bodyPr>
-            <a:normAutofit/>
-          </a:bodyPr>
-          <a:lstStyle/>
-          <a:p>
-            <a:endParaRPr lang="en-US" sz="2400" dirty="0">
-              <a:solidFill>
-                <a:schemeClr val="bg1"/>
-              </a:solidFill>
-              <a:latin typeface="Arial" panose="020B0604020202020204" pitchFamily="34" charset="0"/>
-              <a:ea typeface="+mj-ea"/>
-              <a:cs typeface="Arial" panose="020B0604020202020204" pitchFamily="34" charset="0"/>
-            </a:endParaRPr>
-          </a:p>
-        </p:txBody>
-      </p:sp>
-      <p:pic>
-        <p:nvPicPr>
-          <p:cNvPr id="5" name="Picture 4">
-            <a:extLst>
-              <a:ext uri="{FF2B5EF4-FFF2-40B4-BE49-F238E27FC236}">
-                <a16:creationId xmlns:a16="http://schemas.microsoft.com/office/drawing/2014/main" id="{8425D705-E99B-4E0F-AF12-D0737A2EAB5C}"/>
-              </a:ext>
-            </a:extLst>
-          </p:cNvPr>
-          <p:cNvPicPr>
-            <a:picLocks noChangeAspect="1"/>
-          </p:cNvPicPr>
-          <p:nvPr/>
-        </p:nvPicPr>
-        <p:blipFill>
-          <a:blip r:embed="rId2">
-            <a:extLst>
-              <a:ext uri="{28A0092B-C50C-407E-A947-70E740481C1C}">
-                <a14:useLocalDpi xmlns:a14="http://schemas.microsoft.com/office/drawing/2010/main" val="0"/>
-              </a:ext>
-            </a:extLst>
-          </a:blip>
-          <a:stretch>
-            <a:fillRect/>
-          </a:stretch>
-        </p:blipFill>
-        <p:spPr>
-          <a:xfrm>
-            <a:off x="10985405" y="-352510"/>
-            <a:ext cx="1206595" cy="1206595"/>
-          </a:xfrm>
-          <a:prstGeom prst="rect">
-            <a:avLst/>
-          </a:prstGeom>
-        </p:spPr>
-      </p:pic>
-    </p:spTree>
-    <p:extLst>
-      <p:ext uri="{BB962C8B-B14F-4D97-AF65-F5344CB8AC3E}">
-        <p14:creationId xmlns:p14="http://schemas.microsoft.com/office/powerpoint/2010/main" val="982644715"/>
-      </p:ext>
-    </p:extLst>
-  </p:cSld>
-  <p:clrMapOvr>
-    <a:masterClrMapping/>
-  </p:clrMapOvr>
+  <mc:AlternateContent xmlns:mc="http://schemas.openxmlformats.org/markup-compatibility/2006">
+    <mc:Choice xmlns:p159="http://schemas.microsoft.com/office/powerpoint/2015/09/main" Requires="p159">
+      <p:transition xmlns:p14="http://schemas.microsoft.com/office/powerpoint/2010/main" spd="slow" p14:dur="2000">
+        <p159:morph option="byObject"/>
+      </p:transition>
+    </mc:Choice>
+    <mc:Fallback>
+      <p:transition spd="slow">
+        <p:fade/>
+      </p:transition>
+    </mc:Fallback>
+  </mc:AlternateContent>
 </p:sld>
 </file>
 
@@ -4443,6 +4144,18 @@
   <p:clrMapOvr>
     <a:masterClrMapping/>
   </p:clrMapOvr>
+  <mc:AlternateContent xmlns:mc="http://schemas.openxmlformats.org/markup-compatibility/2006">
+    <mc:Choice xmlns:p159="http://schemas.microsoft.com/office/powerpoint/2015/09/main" Requires="p159">
+      <p:transition xmlns:p14="http://schemas.microsoft.com/office/powerpoint/2010/main" spd="slow" p14:dur="2000">
+        <p159:morph option="byObject"/>
+      </p:transition>
+    </mc:Choice>
+    <mc:Fallback>
+      <p:transition spd="slow">
+        <p:fade/>
+      </p:transition>
+    </mc:Fallback>
+  </mc:AlternateContent>
 </p:sld>
 </file>
 
@@ -4701,6 +4414,18 @@
   <p:clrMapOvr>
     <a:masterClrMapping/>
   </p:clrMapOvr>
+  <mc:AlternateContent xmlns:mc="http://schemas.openxmlformats.org/markup-compatibility/2006">
+    <mc:Choice xmlns:p159="http://schemas.microsoft.com/office/powerpoint/2015/09/main" Requires="p159">
+      <p:transition xmlns:p14="http://schemas.microsoft.com/office/powerpoint/2010/main" spd="slow" p14:dur="2000">
+        <p159:morph option="byObject"/>
+      </p:transition>
+    </mc:Choice>
+    <mc:Fallback>
+      <p:transition spd="slow">
+        <p:fade/>
+      </p:transition>
+    </mc:Fallback>
+  </mc:AlternateContent>
 </p:sld>
 </file>
 
@@ -5017,6 +4742,18 @@
   <p:clrMapOvr>
     <a:masterClrMapping/>
   </p:clrMapOvr>
+  <mc:AlternateContent xmlns:mc="http://schemas.openxmlformats.org/markup-compatibility/2006">
+    <mc:Choice xmlns:p159="http://schemas.microsoft.com/office/powerpoint/2015/09/main" Requires="p159">
+      <p:transition xmlns:p14="http://schemas.microsoft.com/office/powerpoint/2010/main" spd="slow" p14:dur="2000">
+        <p159:morph option="byObject"/>
+      </p:transition>
+    </mc:Choice>
+    <mc:Fallback>
+      <p:transition spd="slow">
+        <p:fade/>
+      </p:transition>
+    </mc:Fallback>
+  </mc:AlternateContent>
 </p:sld>
 </file>
 
@@ -5355,6 +5092,18 @@
   <p:clrMapOvr>
     <a:masterClrMapping/>
   </p:clrMapOvr>
+  <mc:AlternateContent xmlns:mc="http://schemas.openxmlformats.org/markup-compatibility/2006">
+    <mc:Choice xmlns:p159="http://schemas.microsoft.com/office/powerpoint/2015/09/main" Requires="p159">
+      <p:transition xmlns:p14="http://schemas.microsoft.com/office/powerpoint/2010/main" spd="slow" p14:dur="2000">
+        <p159:morph option="byObject"/>
+      </p:transition>
+    </mc:Choice>
+    <mc:Fallback>
+      <p:transition spd="slow">
+        <p:fade/>
+      </p:transition>
+    </mc:Fallback>
+  </mc:AlternateContent>
 </p:sld>
 </file>
 
@@ -5699,6 +5448,18 @@
   <p:clrMapOvr>
     <a:masterClrMapping/>
   </p:clrMapOvr>
+  <mc:AlternateContent xmlns:mc="http://schemas.openxmlformats.org/markup-compatibility/2006">
+    <mc:Choice xmlns:p159="http://schemas.microsoft.com/office/powerpoint/2015/09/main" Requires="p159">
+      <p:transition xmlns:p14="http://schemas.microsoft.com/office/powerpoint/2010/main" spd="slow" p14:dur="2000">
+        <p159:morph option="byObject"/>
+      </p:transition>
+    </mc:Choice>
+    <mc:Fallback>
+      <p:transition spd="slow">
+        <p:fade/>
+      </p:transition>
+    </mc:Fallback>
+  </mc:AlternateContent>
 </p:sld>
 </file>
 
@@ -6054,6 +5815,18 @@
   <p:clrMapOvr>
     <a:masterClrMapping/>
   </p:clrMapOvr>
+  <mc:AlternateContent xmlns:mc="http://schemas.openxmlformats.org/markup-compatibility/2006">
+    <mc:Choice xmlns:p159="http://schemas.microsoft.com/office/powerpoint/2015/09/main" Requires="p159">
+      <p:transition xmlns:p14="http://schemas.microsoft.com/office/powerpoint/2010/main" spd="slow" p14:dur="2000">
+        <p159:morph option="byObject"/>
+      </p:transition>
+    </mc:Choice>
+    <mc:Fallback>
+      <p:transition spd="slow">
+        <p:fade/>
+      </p:transition>
+    </mc:Fallback>
+  </mc:AlternateContent>
 </p:sld>
 </file>
 
@@ -6261,45 +6034,6 @@
           </a:p>
         </p:txBody>
       </p:sp>
-      <p:sp>
-        <p:nvSpPr>
-          <p:cNvPr id="10" name="Content Placeholder 9">
-            <a:extLst>
-              <a:ext uri="{FF2B5EF4-FFF2-40B4-BE49-F238E27FC236}">
-                <a16:creationId xmlns:a16="http://schemas.microsoft.com/office/drawing/2014/main" id="{C2C8480B-C250-44C5-862E-759728BB8DE4}"/>
-              </a:ext>
-            </a:extLst>
-          </p:cNvPr>
-          <p:cNvSpPr>
-            <a:spLocks noGrp="1"/>
-          </p:cNvSpPr>
-          <p:nvPr>
-            <p:ph sz="half" idx="2"/>
-          </p:nvPr>
-        </p:nvSpPr>
-        <p:spPr>
-          <a:xfrm>
-            <a:off x="6172200" y="1825625"/>
-            <a:ext cx="5763126" cy="4667250"/>
-          </a:xfrm>
-        </p:spPr>
-        <p:txBody>
-          <a:bodyPr>
-            <a:normAutofit/>
-          </a:bodyPr>
-          <a:lstStyle/>
-          <a:p>
-            <a:endParaRPr lang="en-US" sz="2400" dirty="0">
-              <a:solidFill>
-                <a:schemeClr val="bg1"/>
-              </a:solidFill>
-              <a:latin typeface="Arial" panose="020B0604020202020204" pitchFamily="34" charset="0"/>
-              <a:ea typeface="+mj-ea"/>
-              <a:cs typeface="Arial" panose="020B0604020202020204" pitchFamily="34" charset="0"/>
-            </a:endParaRPr>
-          </a:p>
-        </p:txBody>
-      </p:sp>
       <p:pic>
         <p:nvPicPr>
           <p:cNvPr id="5" name="Picture 4">
@@ -6330,6 +6064,37 @@
           <a:xfrm>
             <a:off x="10985405" y="-352510"/>
             <a:ext cx="1206595" cy="1206595"/>
+          </a:xfrm>
+          <a:prstGeom prst="rect">
+            <a:avLst/>
+          </a:prstGeom>
+        </p:spPr>
+      </p:pic>
+      <p:pic>
+        <p:nvPicPr>
+          <p:cNvPr id="7" name="Content Placeholder 6">
+            <a:extLst>
+              <a:ext uri="{FF2B5EF4-FFF2-40B4-BE49-F238E27FC236}">
+                <a16:creationId xmlns:a16="http://schemas.microsoft.com/office/drawing/2014/main" id="{428400DA-F71B-475F-B8DC-1151013CE883}"/>
+              </a:ext>
+            </a:extLst>
+          </p:cNvPr>
+          <p:cNvPicPr>
+            <a:picLocks noGrp="1" noChangeAspect="1"/>
+          </p:cNvPicPr>
+          <p:nvPr>
+            <p:ph sz="half" idx="2"/>
+          </p:nvPr>
+        </p:nvPicPr>
+        <p:blipFill rotWithShape="1">
+          <a:blip r:embed="rId3"/>
+          <a:srcRect t="6655" b="7114"/>
+          <a:stretch/>
+        </p:blipFill>
+        <p:spPr>
+          <a:xfrm>
+            <a:off x="6968331" y="1825625"/>
+            <a:ext cx="4351338" cy="3752215"/>
           </a:xfrm>
           <a:prstGeom prst="rect">
             <a:avLst/>
@@ -6346,6 +6111,18 @@
   <p:clrMapOvr>
     <a:masterClrMapping/>
   </p:clrMapOvr>
+  <mc:AlternateContent xmlns:mc="http://schemas.openxmlformats.org/markup-compatibility/2006">
+    <mc:Choice xmlns:p159="http://schemas.microsoft.com/office/powerpoint/2015/09/main" Requires="p159">
+      <p:transition xmlns:p14="http://schemas.microsoft.com/office/powerpoint/2010/main" spd="slow" p14:dur="2000">
+        <p159:morph option="byObject"/>
+      </p:transition>
+    </mc:Choice>
+    <mc:Fallback>
+      <p:transition spd="slow">
+        <p:fade/>
+      </p:transition>
+    </mc:Fallback>
+  </mc:AlternateContent>
 </p:sld>
 </file>
 
@@ -6366,129 +6143,43 @@
           <a:chExt cx="0" cy="0"/>
         </a:xfrm>
       </p:grpSpPr>
-      <p:sp>
-        <p:nvSpPr>
-          <p:cNvPr id="8" name="Title 7">
-            <a:extLst>
-              <a:ext uri="{FF2B5EF4-FFF2-40B4-BE49-F238E27FC236}">
-                <a16:creationId xmlns:a16="http://schemas.microsoft.com/office/drawing/2014/main" id="{658724C2-AA3C-463E-BA7F-66917BC7A333}"/>
-              </a:ext>
-            </a:extLst>
-          </p:cNvPr>
-          <p:cNvSpPr>
-            <a:spLocks noGrp="1"/>
-          </p:cNvSpPr>
-          <p:nvPr>
-            <p:ph type="title"/>
-          </p:nvPr>
-        </p:nvSpPr>
+      <p:pic>
+        <p:nvPicPr>
+          <p:cNvPr id="2" name="Content Placeholder 1">
+            <a:extLst>
+              <a:ext uri="{FF2B5EF4-FFF2-40B4-BE49-F238E27FC236}">
+                <a16:creationId xmlns:a16="http://schemas.microsoft.com/office/drawing/2014/main" id="{1B723469-4F2C-4B51-849D-B0EB561C139A}"/>
+              </a:ext>
+            </a:extLst>
+          </p:cNvPr>
+          <p:cNvPicPr>
+            <a:picLocks noGrp="1" noChangeAspect="1"/>
+          </p:cNvPicPr>
+          <p:nvPr>
+            <p:ph sz="half" idx="1"/>
+          </p:nvPr>
+        </p:nvPicPr>
+        <p:blipFill rotWithShape="1">
+          <a:blip r:embed="rId2"/>
+          <a:srcRect l="11915" t="27246" r="11915" b="25974"/>
+          <a:stretch/>
+        </p:blipFill>
         <p:spPr>
           <a:xfrm>
-            <a:off x="224589" y="365125"/>
-            <a:ext cx="11710737" cy="1325563"/>
+            <a:off x="2621280" y="1539240"/>
+            <a:ext cx="6537960" cy="3916680"/>
           </a:xfrm>
+          <a:prstGeom prst="rect">
+            <a:avLst/>
+          </a:prstGeom>
         </p:spPr>
-        <p:txBody>
-          <a:bodyPr/>
-          <a:lstStyle/>
-          <a:p>
-            <a:r>
-              <a:rPr lang="en-US" b="1" dirty="0">
-                <a:solidFill>
-                  <a:schemeClr val="bg1"/>
-                </a:solidFill>
-                <a:latin typeface="Arial" panose="020B0604020202020204" pitchFamily="34" charset="0"/>
-                <a:cs typeface="Arial" panose="020B0604020202020204" pitchFamily="34" charset="0"/>
-              </a:rPr>
-              <a:t>Executive Summary (The "Bottom Line")</a:t>
-            </a:r>
-          </a:p>
-        </p:txBody>
-      </p:sp>
-      <p:sp>
-        <p:nvSpPr>
-          <p:cNvPr id="9" name="Content Placeholder 8">
-            <a:extLst>
-              <a:ext uri="{FF2B5EF4-FFF2-40B4-BE49-F238E27FC236}">
-                <a16:creationId xmlns:a16="http://schemas.microsoft.com/office/drawing/2014/main" id="{58DE8E8D-A5A9-46A2-AD26-B6EE25640764}"/>
-              </a:ext>
-            </a:extLst>
-          </p:cNvPr>
-          <p:cNvSpPr>
-            <a:spLocks noGrp="1"/>
-          </p:cNvSpPr>
-          <p:nvPr>
-            <p:ph sz="half" idx="1"/>
-          </p:nvPr>
-        </p:nvSpPr>
-        <p:spPr>
-          <a:xfrm>
-            <a:off x="224589" y="1825625"/>
-            <a:ext cx="5795211" cy="4667250"/>
-          </a:xfrm>
-        </p:spPr>
-        <p:txBody>
-          <a:bodyPr>
-            <a:normAutofit/>
-          </a:bodyPr>
-          <a:lstStyle/>
-          <a:p>
-            <a:endParaRPr lang="en-US" sz="2400" dirty="0">
-              <a:solidFill>
-                <a:schemeClr val="bg1"/>
-              </a:solidFill>
-              <a:latin typeface="Arial" panose="020B0604020202020204" pitchFamily="34" charset="0"/>
-              <a:ea typeface="+mj-ea"/>
-              <a:cs typeface="Arial" panose="020B0604020202020204" pitchFamily="34" charset="0"/>
-            </a:endParaRPr>
-          </a:p>
-        </p:txBody>
-      </p:sp>
-      <p:sp>
-        <p:nvSpPr>
-          <p:cNvPr id="10" name="Content Placeholder 9">
-            <a:extLst>
-              <a:ext uri="{FF2B5EF4-FFF2-40B4-BE49-F238E27FC236}">
-                <a16:creationId xmlns:a16="http://schemas.microsoft.com/office/drawing/2014/main" id="{C2C8480B-C250-44C5-862E-759728BB8DE4}"/>
-              </a:ext>
-            </a:extLst>
-          </p:cNvPr>
-          <p:cNvSpPr>
-            <a:spLocks noGrp="1"/>
-          </p:cNvSpPr>
-          <p:nvPr>
-            <p:ph sz="half" idx="2"/>
-          </p:nvPr>
-        </p:nvSpPr>
-        <p:spPr>
-          <a:xfrm>
-            <a:off x="6172200" y="1825625"/>
-            <a:ext cx="5763126" cy="4667250"/>
-          </a:xfrm>
-        </p:spPr>
-        <p:txBody>
-          <a:bodyPr>
-            <a:normAutofit/>
-          </a:bodyPr>
-          <a:lstStyle/>
-          <a:p>
-            <a:endParaRPr lang="en-US" sz="2400" dirty="0">
-              <a:solidFill>
-                <a:schemeClr val="bg1"/>
-              </a:solidFill>
-              <a:latin typeface="Arial" panose="020B0604020202020204" pitchFamily="34" charset="0"/>
-              <a:ea typeface="+mj-ea"/>
-              <a:cs typeface="Arial" panose="020B0604020202020204" pitchFamily="34" charset="0"/>
-            </a:endParaRPr>
-          </a:p>
-        </p:txBody>
-      </p:sp>
+      </p:pic>
       <p:pic>
         <p:nvPicPr>
-          <p:cNvPr id="5" name="Picture 4">
-            <a:extLst>
-              <a:ext uri="{FF2B5EF4-FFF2-40B4-BE49-F238E27FC236}">
-                <a16:creationId xmlns:a16="http://schemas.microsoft.com/office/drawing/2014/main" id="{8425D705-E99B-4E0F-AF12-D0737A2EAB5C}"/>
+          <p:cNvPr id="7" name="Picture 6">
+            <a:extLst>
+              <a:ext uri="{FF2B5EF4-FFF2-40B4-BE49-F238E27FC236}">
+                <a16:creationId xmlns:a16="http://schemas.microsoft.com/office/drawing/2014/main" id="{8267FE16-30E5-4840-BC7C-8CED7870FBF7}"/>
               </a:ext>
             </a:extLst>
           </p:cNvPr>
@@ -6498,7 +6189,7 @@
           <p:nvPr/>
         </p:nvPicPr>
         <p:blipFill>
-          <a:blip r:embed="rId2">
+          <a:blip r:embed="rId3">
             <a:extLst>
               <a:ext uri="{28A0092B-C50C-407E-A947-70E740481C1C}">
                 <a14:useLocalDpi xmlns:a14="http://schemas.microsoft.com/office/drawing/2010/main" val="0"/>
@@ -6511,8 +6202,8 @@
         </p:blipFill>
         <p:spPr>
           <a:xfrm>
-            <a:off x="10985405" y="-352510"/>
-            <a:ext cx="1206595" cy="1206595"/>
+            <a:off x="5024436" y="-552109"/>
+            <a:ext cx="2143125" cy="2143125"/>
           </a:xfrm>
           <a:prstGeom prst="rect">
             <a:avLst/>
@@ -6529,6 +6220,18 @@
   <p:clrMapOvr>
     <a:masterClrMapping/>
   </p:clrMapOvr>
+  <mc:AlternateContent xmlns:mc="http://schemas.openxmlformats.org/markup-compatibility/2006">
+    <mc:Choice xmlns:p159="http://schemas.microsoft.com/office/powerpoint/2015/09/main" Requires="p159">
+      <p:transition xmlns:p14="http://schemas.microsoft.com/office/powerpoint/2010/main" spd="slow" p14:dur="2000">
+        <p159:morph option="byObject"/>
+      </p:transition>
+    </mc:Choice>
+    <mc:Fallback>
+      <p:transition spd="slow">
+        <p:fade/>
+      </p:transition>
+    </mc:Fallback>
+  </mc:AlternateContent>
 </p:sld>
 </file>
 

</xml_diff>